<commit_message>
Deploy OpsMind to Cloud Run and point every artifact at it
Cloud Run was the one submission field the Vercel deployment could not
satisfy. Add scripts/deploy-cloud-run.sh (billing preflight, API enable,
Secret Manager for DATABASE_URL and GEMINI_API_KEY, deploy from source,
/api/health smoke test) and move DATABASE_URL out of plain revision env vars.
Re-record the demo, captions, voice-over and both decks against the Cloud Run
URL so the prototype link, video and deck all describe the same deployment.

🤖 Generated with Codebuff
Co-Authored-By: Codebuff <noreply@codebuff.com>
</commit_message>
<xml_diff>
--- a/submission/OpsMind_AI_Deck_EN.pptx
+++ b/submission/OpsMind_AI_Deck_EN.pptx
@@ -8667,7 +8667,7 @@
                 </a:solidFill>
                 <a:latin typeface="Arial"/>
               </a:rPr>
-              <a:t>• GitHub public repository: see the Hack2skill submission form.</a:t>
+              <a:t>• GitHub public repository: https://github.com/Elwyun/opsmind</a:t>
             </a:r>
           </a:p>
           <a:p>
@@ -8686,7 +8686,7 @@
                 </a:solidFill>
                 <a:latin typeface="Arial"/>
               </a:rPr>
-              <a:t>• Demo video (&lt;3 min): see the submission form.</a:t>
+              <a:t>• Demo video (&lt;3 min): https://drive.google.com/file/d/1MbWaVnI91_w6GK38qvh7ldsoKX-j5wls/view</a:t>
             </a:r>
           </a:p>
           <a:p>
@@ -8705,7 +8705,7 @@
                 </a:solidFill>
                 <a:latin typeface="Arial"/>
               </a:rPr>
-              <a:t>• Live prototype: see the submission form.</a:t>
+              <a:t>• Live prototype: https://opsmind-483387477810.asia-southeast1.run.app</a:t>
             </a:r>
           </a:p>
           <a:p>

</xml_diff>